<commit_message>
Convert & read fixes from corpus testing; paywall colours; rename to FoldScan
- Office: keep recognized lines together (CJK interleaving), two-column pages
  as Word columns, outline-only tables rebuilt from aligned columns, wrapped
  row labels, spaces between columns, no tables from column prose, XML-safe
  text, sideways pages turned upright, small images enlarged, bold calibrated
  (incl. CJK, local light).
- Math: tolerant solver for photographed sheets (numbering, =, superscripts,
  √, x/÷), never merges "2 57" into 257.
- Photo translation: clamp edge boxes, light text on dark/colored signs.
- ConvertCorpusTests harness (private corpus, skipped when absent).
- Paywall: each slide its own stage colour. Extract text glyph square.
- App name FoldScan.

Co-Authored-By: Claude Opus 5.5 <noreply@anthropic.com>
Claude-Session: https://claude.ai/code/session_01N2KPqXq9Whv7eR2vrvkBWC
</commit_message>
<xml_diff>
--- a/ios/Verification/office-layout/OfficeSamplePhoto.pptx
+++ b/ios/Verification/office-layout/OfficeSamplePhoto.pptx
@@ -372,7 +372,7 @@
                     <a:p>
                       <a:pPr algn="l"/>
                       <a:r>
-                        <a:rPr lang="en-US" sz="1200" dirty="0">
+                        <a:rPr lang="en-US" sz="1200" b="1" dirty="0">
                           <a:solidFill>
                             <a:srgbClr val="000000"/>
                           </a:solidFill>
@@ -415,7 +415,7 @@
                           <a:ea typeface="Malgun Gothic"/>
                           <a:cs typeface="Arial"/>
                         </a:rPr>
-                        <a:t>476 - 479</a:t>
+                        <a:t>476-479</a:t>
                       </a:r>
                     </a:p>
                   </a:txBody>
@@ -546,7 +546,18 @@
                           <a:ea typeface="Malgun Gothic"/>
                           <a:cs typeface="Arial"/>
                         </a:rPr>
-                        <a:t>518 - 689</a:t>
+                        <a:t>518 -</a:t>
+                      </a:r>
+                      <a:r>
+                        <a:rPr lang="en-US" sz="1200" b="1" dirty="0">
+                          <a:solidFill>
+                            <a:srgbClr val="000000"/>
+                          </a:solidFill>
+                          <a:latin typeface="Arial"/>
+                          <a:ea typeface="Malgun Gothic"/>
+                          <a:cs typeface="Arial"/>
+                        </a:rPr>
+                        <a:t> 689</a:t>
                       </a:r>
                     </a:p>
                   </a:txBody>
@@ -688,7 +699,7 @@
                           <a:ea typeface="Malgun Gothic"/>
                           <a:cs typeface="Arial"/>
                         </a:rPr>
-                        <a:t>644 - 769</a:t>
+                        <a:t>644-769</a:t>
                       </a:r>
                     </a:p>
                   </a:txBody>
@@ -830,7 +841,7 @@
                           <a:ea typeface="Malgun Gothic"/>
                           <a:cs typeface="Arial"/>
                         </a:rPr>
-                        <a:t>801 - 989</a:t>
+                        <a:t>801-989</a:t>
                       </a:r>
                     </a:p>
                   </a:txBody>
@@ -972,7 +983,7 @@
                           <a:ea typeface="Malgun Gothic"/>
                           <a:cs typeface="Arial"/>
                         </a:rPr>
-                        <a:t>834 - 1,062</a:t>
+                        <a:t>834-1,062</a:t>
                       </a:r>
                     </a:p>
                   </a:txBody>
@@ -1256,7 +1267,7 @@
                           <a:ea typeface="Malgun Gothic"/>
                           <a:cs typeface="Arial"/>
                         </a:rPr>
-                        <a:t>1,338 - 1,553</a:t>
+                        <a:t>1,338-1,553</a:t>
                       </a:r>
                     </a:p>
                   </a:txBody>
@@ -1471,7 +1482,7 @@
               <a:buNone/>
             </a:pPr>
             <a:r>
-              <a:rPr lang="en-US" sz="1000" dirty="0">
+              <a:rPr lang="en-US" sz="1000" b="1" spc="-27" dirty="0">
                 <a:solidFill>
                   <a:srgbClr val="000000"/>
                 </a:solidFill>
@@ -1984,7 +1995,7 @@
               </a:lnSpc>
             </a:pPr>
             <a:r>
-              <a:rPr lang="en-US" sz="1400" dirty="0">
+              <a:rPr lang="en-US" sz="1400" b="1" dirty="0">
                 <a:solidFill>
                   <a:srgbClr val="000000"/>
                 </a:solidFill>

</xml_diff>

<commit_message>
Sharper scans: 48 MP capture in good light, supersampled clarity step
- Camera: good light captures at the sensor's full 48 MP and decodes
  straight to ~24 MP with ImageIO (orientation applied); dim light keeps
  the ~12 MP three-frame burst.
- Clarity: pages with a long side under 3600 px run the stroke step at
  up to 2x and scale back, so letter edges stay antialiased instead of
  snapping to whole pixels. Page size and coordinates are unchanged.
- Ink ramp (0.18, 0.55) -> (0.14, 0.65); 0.12-0.8 loses thin printed
  checkboxes on the Notice sample.
- Sharpness test reads the phone scan with its saved crop.

Co-Authored-By: Claude Opus 5.5 <noreply@anthropic.com>
Claude-Session: https://claude.ai/code/session_01N2KPqXq9Whv7eR2vrvkBWC
</commit_message>
<xml_diff>
--- a/ios/Verification/office-layout/OfficeSamplePhoto.pptx
+++ b/ios/Verification/office-layout/OfficeSamplePhoto.pptx
@@ -110,7 +110,7 @@
         <p:spPr>
           <a:xfrm>
             <a:off x="417310" y="268271"/>
-            <a:ext cx="491830" cy="59616"/>
+            <a:ext cx="476926" cy="59616"/>
           </a:xfrm>
           <a:prstGeom prst="rect">
             <a:avLst/>
@@ -141,41 +141,17 @@
           </a:prstGeom>
         </p:spPr>
       </p:pic>
-      <p:pic>
-        <p:nvPicPr>
-          <p:cNvPr id="4" name="Picture 4"/>
-          <p:cNvPicPr>
-            <a:picLocks noChangeAspect="1"/>
-          </p:cNvPicPr>
-          <p:nvPr/>
-        </p:nvPicPr>
-        <p:blipFill>
-          <a:blip r:embed="rId4"/>
-          <a:stretch>
-            <a:fillRect/>
-          </a:stretch>
-        </p:blipFill>
-        <p:spPr>
-          <a:xfrm>
-            <a:off x="1550009" y="1386066"/>
-            <a:ext cx="789908" cy="44712"/>
-          </a:xfrm>
-          <a:prstGeom prst="rect">
-            <a:avLst/>
-          </a:prstGeom>
-        </p:spPr>
-      </p:pic>
       <p:graphicFrame>
         <p:nvGraphicFramePr>
-          <p:cNvPr id="5" name="Table 5"/>
+          <p:cNvPr id="4" name="Table 4"/>
           <p:cNvGraphicFramePr>
             <a:graphicFrameLocks noGrp="1"/>
           </p:cNvGraphicFramePr>
           <p:nvPr/>
         </p:nvGraphicFramePr>
         <p:xfrm>
-          <a:off x="1054453" y="3062953"/>
-          <a:ext cx="5588975" cy="2376861"/>
+          <a:off x="1054453" y="3069066"/>
+          <a:ext cx="5588975" cy="2370748"/>
         </p:xfrm>
         <a:graphic>
           <a:graphicData uri="http://schemas.openxmlformats.org/drawingml/2006/table">
@@ -183,11 +159,11 @@
               <a:tblPr/>
               <a:tblGrid>
                 <a:gridCol w="1754938"/>
-                <a:gridCol w="1121521"/>
-                <a:gridCol w="1382340"/>
+                <a:gridCol w="1119658"/>
+                <a:gridCol w="1384203"/>
                 <a:gridCol w="1330176"/>
               </a:tblGrid>
-              <a:tr h="320702">
+              <a:tr h="314589">
                 <a:tc>
                   <a:txBody>
                     <a:bodyPr/>
@@ -471,7 +447,7 @@
                   </a:tcPr>
                 </a:tc>
               </a:tr>
-              <a:tr h="277491">
+              <a:tr h="277214">
                 <a:tc>
                   <a:txBody>
                     <a:bodyPr/>
@@ -613,7 +589,7 @@
                   </a:tcPr>
                 </a:tc>
               </a:tr>
-              <a:tr h="279015">
+              <a:tr h="279685">
                 <a:tc>
                   <a:txBody>
                     <a:bodyPr/>
@@ -755,7 +731,7 @@
                   </a:tcPr>
                 </a:tc>
               </a:tr>
-              <a:tr h="294169">
+              <a:tr h="293988">
                 <a:tc>
                   <a:txBody>
                     <a:bodyPr/>
@@ -897,7 +873,7 @@
                   </a:tcPr>
                 </a:tc>
               </a:tr>
-              <a:tr h="311152">
+              <a:tr h="310940">
                 <a:tc>
                   <a:txBody>
                     <a:bodyPr/>
@@ -1329,14 +1305,14 @@
       </p:graphicFrame>
       <p:sp>
         <p:nvSpPr>
-          <p:cNvPr id="6" name="Text 6"/>
+          <p:cNvPr id="5" name="Text 5"/>
           <p:cNvSpPr txBox="1"/>
           <p:nvPr/>
         </p:nvSpPr>
         <p:spPr>
           <a:xfrm>
-            <a:off x="1058179" y="755523"/>
-            <a:ext cx="1821074" cy="419100"/>
+            <a:off x="1032097" y="755523"/>
+            <a:ext cx="1853676" cy="419100"/>
           </a:xfrm>
           <a:prstGeom prst="rect">
             <a:avLst/>
@@ -1356,7 +1332,7 @@
               <a:buNone/>
             </a:pPr>
             <a:r>
-              <a:rPr lang="en-US" sz="2173" spc="155" dirty="0">
+              <a:rPr lang="en-US" sz="2174" spc="196" dirty="0">
                 <a:solidFill>
                   <a:srgbClr val="000000"/>
                 </a:solidFill>
@@ -1371,14 +1347,14 @@
       </p:sp>
       <p:sp>
         <p:nvSpPr>
-          <p:cNvPr id="7" name="Text 7"/>
+          <p:cNvPr id="6" name="Text 6"/>
           <p:cNvSpPr txBox="1"/>
           <p:nvPr/>
         </p:nvSpPr>
         <p:spPr>
           <a:xfrm>
-            <a:off x="1140151" y="1160190"/>
-            <a:ext cx="1984086" cy="137160"/>
+            <a:off x="1143877" y="1171620"/>
+            <a:ext cx="1974771" cy="114300"/>
           </a:xfrm>
           <a:prstGeom prst="rect">
             <a:avLst/>
@@ -1393,12 +1369,12 @@
           <a:p>
             <a:pPr algn="l">
               <a:lnSpc>
-                <a:spcPts val="1080"/>
+                <a:spcPts val="900"/>
               </a:lnSpc>
               <a:buNone/>
             </a:pPr>
             <a:r>
-              <a:rPr lang="en-US" sz="900" spc="100" dirty="0">
+              <a:rPr lang="en-US" sz="750" spc="196" dirty="0">
                 <a:solidFill>
                   <a:srgbClr val="000000"/>
                 </a:solidFill>
@@ -1413,14 +1389,14 @@
       </p:sp>
       <p:sp>
         <p:nvSpPr>
-          <p:cNvPr id="8" name="Text 8"/>
+          <p:cNvPr id="7" name="Text 7"/>
           <p:cNvSpPr txBox="1"/>
           <p:nvPr/>
         </p:nvSpPr>
         <p:spPr>
           <a:xfrm>
-            <a:off x="2521559" y="2148658"/>
-            <a:ext cx="2841062" cy="220980"/>
+            <a:off x="2522025" y="2148658"/>
+            <a:ext cx="2836404" cy="220980"/>
           </a:xfrm>
           <a:prstGeom prst="rect">
             <a:avLst/>
@@ -1440,7 +1416,7 @@
               <a:buNone/>
             </a:pPr>
             <a:r>
-              <a:rPr lang="en-US" sz="1450" b="1" spc="-31" dirty="0">
+              <a:rPr lang="en-US" sz="1450" b="1" spc="-32" dirty="0">
                 <a:solidFill>
                   <a:srgbClr val="000000"/>
                 </a:solidFill>
@@ -1455,7 +1431,7 @@
       </p:sp>
       <p:sp>
         <p:nvSpPr>
-          <p:cNvPr id="9" name="Text 9"/>
+          <p:cNvPr id="8" name="Text 8"/>
           <p:cNvSpPr txBox="1"/>
           <p:nvPr/>
         </p:nvSpPr>
@@ -1490,14 +1466,25 @@
                 <a:ea typeface="Malgun Gothic"/>
                 <a:cs typeface="Arial"/>
               </a:rPr>
-              <a:t>October 2021</a:t>
+              <a:t>October</a:t>
+            </a:r>
+            <a:r>
+              <a:rPr lang="en-US" sz="1000" spc="-27" dirty="0">
+                <a:solidFill>
+                  <a:srgbClr val="000000"/>
+                </a:solidFill>
+                <a:latin typeface="Arial"/>
+                <a:ea typeface="Malgun Gothic"/>
+                <a:cs typeface="Arial"/>
+              </a:rPr>
+              <a:t> 2021</a:t>
             </a:r>
           </a:p>
         </p:txBody>
       </p:sp>
       <p:sp>
         <p:nvSpPr>
-          <p:cNvPr id="10" name="Text 10"/>
+          <p:cNvPr id="9" name="Text 9"/>
           <p:cNvSpPr txBox="1"/>
           <p:nvPr/>
         </p:nvSpPr>
@@ -1539,7 +1526,7 @@
       </p:sp>
       <p:sp>
         <p:nvSpPr>
-          <p:cNvPr id="11" name="Text 11"/>
+          <p:cNvPr id="10" name="Text 10"/>
           <p:cNvSpPr txBox="1"/>
           <p:nvPr/>
         </p:nvSpPr>
@@ -1582,7 +1569,7 @@
       </p:sp>
       <p:sp>
         <p:nvSpPr>
-          <p:cNvPr id="12" name="Text 12"/>
+          <p:cNvPr id="11" name="Text 11"/>
           <p:cNvSpPr txBox="1"/>
           <p:nvPr/>
         </p:nvSpPr>
@@ -1625,14 +1612,14 @@
       </p:sp>
       <p:sp>
         <p:nvSpPr>
-          <p:cNvPr id="13" name="Text 13"/>
+          <p:cNvPr id="12" name="Text 12"/>
           <p:cNvSpPr txBox="1"/>
           <p:nvPr/>
         </p:nvSpPr>
         <p:spPr>
           <a:xfrm>
-            <a:off x="1292916" y="6529687"/>
-            <a:ext cx="1383271" cy="144780"/>
+            <a:off x="1241831" y="6529687"/>
+            <a:ext cx="1447128" cy="144780"/>
           </a:xfrm>
           <a:prstGeom prst="rect">
             <a:avLst/>
@@ -1645,7 +1632,7 @@
           </a:bodyPr>
           <a:lstStyle/>
           <a:p>
-            <a:pPr algn="l" marL="216107" indent="-216107">
+            <a:pPr algn="l" marL="267192" indent="-267192">
               <a:lnSpc>
                 <a:spcPts val="1140"/>
               </a:lnSpc>
@@ -1668,7 +1655,7 @@
       </p:sp>
       <p:sp>
         <p:nvSpPr>
-          <p:cNvPr id="14" name="Text 14"/>
+          <p:cNvPr id="13" name="Text 13"/>
           <p:cNvSpPr txBox="1"/>
           <p:nvPr/>
         </p:nvSpPr>
@@ -1711,13 +1698,13 @@
       </p:sp>
       <p:sp>
         <p:nvSpPr>
-          <p:cNvPr id="15" name="Text 15"/>
+          <p:cNvPr id="14" name="Text 14"/>
           <p:cNvSpPr txBox="1"/>
           <p:nvPr/>
         </p:nvSpPr>
         <p:spPr>
           <a:xfrm>
-            <a:off x="1289190" y="6847792"/>
+            <a:off x="1289190" y="6855065"/>
             <a:ext cx="1415873" cy="152400"/>
           </a:xfrm>
           <a:prstGeom prst="rect">
@@ -1754,7 +1741,7 @@
       </p:sp>
       <p:sp>
         <p:nvSpPr>
-          <p:cNvPr id="16" name="Text 16"/>
+          <p:cNvPr id="15" name="Text 15"/>
           <p:cNvSpPr txBox="1"/>
           <p:nvPr/>
         </p:nvSpPr>
@@ -1808,7 +1795,7 @@
       </p:sp>
       <p:sp>
         <p:nvSpPr>
-          <p:cNvPr id="17" name="Text 17"/>
+          <p:cNvPr id="16" name="Text 16"/>
           <p:cNvSpPr txBox="1"/>
           <p:nvPr/>
         </p:nvSpPr>
@@ -1835,7 +1822,7 @@
               <a:buNone/>
             </a:pPr>
             <a:r>
-              <a:rPr lang="en-US" sz="650" spc="10" dirty="0">
+              <a:rPr lang="en-US" sz="650" spc="11" dirty="0">
                 <a:solidFill>
                   <a:srgbClr val="000000"/>
                 </a:solidFill>
@@ -1843,7 +1830,7 @@
                 <a:ea typeface="Malgun Gothic"/>
                 <a:cs typeface="Arial"/>
               </a:rPr>
-              <a:t>rices do not include GST, may change without notice and are subject to availability. Sulte sizes may vary on final Strata Plan. Concert reserves the right t</a:t>
+              <a:t>Prices do not include GST, may change without notice and are subject to availability. Sulte sizes may vary on final Strata Plan. Concert reserves the right to</a:t>
             </a:r>
             <a:r>
               <a:rPr lang="en-US" sz="650" dirty="0">
@@ -1857,7 +1844,7 @@
               <a:t> </a:t>
             </a:r>
             <a:r>
-              <a:rPr lang="en-US" sz="600" spc="10" dirty="0">
+              <a:rPr lang="en-US" sz="600" spc="11" dirty="0">
                 <a:solidFill>
                   <a:srgbClr val="000000"/>
                 </a:solidFill>
@@ -1865,21 +1852,21 @@
                 <a:ea typeface="Malgun Gothic"/>
                 <a:cs typeface="Arial"/>
               </a:rPr>
-              <a:t>make modifications and changes to floorplans, project design, specifications and features. October 2021. CONCERT REALTY SERVICES LTD. E.&amp;O.E.</a:t>
+              <a:t>nake modifications and changes to floorplans, project design, specifications and features. October 2021. CONCERT REALTY SERVICES LTD. E.8O.!</a:t>
             </a:r>
           </a:p>
         </p:txBody>
       </p:sp>
       <p:sp>
         <p:nvSpPr>
-          <p:cNvPr id="18" name="Text 18"/>
+          <p:cNvPr id="17" name="Text 17"/>
           <p:cNvSpPr txBox="1"/>
           <p:nvPr/>
         </p:nvSpPr>
         <p:spPr>
           <a:xfrm>
             <a:off x="1069357" y="8798979"/>
-            <a:ext cx="2375314" cy="263202"/>
+            <a:ext cx="2370657" cy="248579"/>
           </a:xfrm>
           <a:prstGeom prst="rect">
             <a:avLst/>
@@ -1894,7 +1881,7 @@
           <a:p>
             <a:pPr algn="l">
               <a:lnSpc>
-                <a:spcPts val="1036"/>
+                <a:spcPts val="979"/>
               </a:lnSpc>
               <a:buNone/>
             </a:pPr>
@@ -1928,14 +1915,14 @@
       </p:sp>
       <p:sp>
         <p:nvSpPr>
-          <p:cNvPr id="19" name="Text 19"/>
+          <p:cNvPr id="18" name="Text 18"/>
           <p:cNvSpPr txBox="1"/>
           <p:nvPr/>
         </p:nvSpPr>
         <p:spPr>
           <a:xfrm>
-            <a:off x="1061905" y="9063082"/>
-            <a:ext cx="2920239" cy="121920"/>
+            <a:off x="1065631" y="9066892"/>
+            <a:ext cx="2915581" cy="114300"/>
           </a:xfrm>
           <a:prstGeom prst="rect">
             <a:avLst/>
@@ -1950,11 +1937,11 @@
           <a:p>
             <a:pPr algn="l">
               <a:lnSpc>
-                <a:spcPts val="960"/>
+                <a:spcPts val="900"/>
               </a:lnSpc>
             </a:pPr>
             <a:r>
-              <a:rPr lang="en-US" sz="800" dirty="0">
+              <a:rPr lang="en-US" sz="750" dirty="0">
                 <a:solidFill>
                   <a:srgbClr val="000000"/>
                 </a:solidFill>
@@ -1969,14 +1956,14 @@
       </p:sp>
       <p:sp>
         <p:nvSpPr>
-          <p:cNvPr id="20" name="Text 20"/>
+          <p:cNvPr id="19" name="Text 19"/>
           <p:cNvSpPr txBox="1"/>
           <p:nvPr/>
         </p:nvSpPr>
         <p:spPr>
           <a:xfrm>
-            <a:off x="5827437" y="9056054"/>
-            <a:ext cx="1248204" cy="121920"/>
+            <a:off x="5827437" y="9059864"/>
+            <a:ext cx="1248204" cy="114300"/>
           </a:xfrm>
           <a:prstGeom prst="rect">
             <a:avLst/>
@@ -1991,7 +1978,7 @@
           <a:p>
             <a:pPr algn="l">
               <a:lnSpc>
-                <a:spcPts val="960"/>
+                <a:spcPts val="900"/>
               </a:lnSpc>
             </a:pPr>
             <a:r>

</xml_diff>

<commit_message>
Packing list: page frame, banded tables, numbered columns; flatter, crisper scan
- Layout: the page frame gives its sides back as cell walls; collinear rule
  pieces join; tables split into bands of matching walls; empty merged cells
  are split along shared row/column lines; a logo bar in a cell becomes a picture.
- Re-reading: numbered columns are filled and corrected from their sequence;
  a sign never turns into a letter, and a capital never into its small letter.
- Excel: row edges from every band; table cells shrink to fit.
- Scan: the flatten mesh samples through a homography plus offsets (straight
  rules); the paper background is lifted to white so text reads clearly.
- UI test: settle the Welcome to Pro card before opening the saved document.

Co-Authored-By: Claude Opus 5.5 <noreply@anthropic.com>
Claude-Session: https://claude.ai/code/session_01N2KPqXq9Whv7eR2vrvkBWC
</commit_message>
<xml_diff>
--- a/ios/Verification/office-layout/OfficeSamplePhoto.pptx
+++ b/ios/Verification/office-layout/OfficeSamplePhoto.pptx
@@ -150,8 +150,8 @@
           <p:nvPr/>
         </p:nvGraphicFramePr>
         <p:xfrm>
-          <a:off x="1054453" y="3069066"/>
-          <a:ext cx="5588975" cy="2370748"/>
+          <a:off x="1054453" y="3057212"/>
+          <a:ext cx="5588975" cy="2377199"/>
         </p:xfrm>
         <a:graphic>
           <a:graphicData uri="http://schemas.openxmlformats.org/drawingml/2006/table">
@@ -163,7 +163,7 @@
                 <a:gridCol w="1384203"/>
                 <a:gridCol w="1330176"/>
               </a:tblGrid>
-              <a:tr h="314589">
+              <a:tr h="318970">
                 <a:tc>
                   <a:txBody>
                     <a:bodyPr/>
@@ -305,7 +305,7 @@
                   </a:tcPr>
                 </a:tc>
               </a:tr>
-              <a:tr h="315692">
+              <a:tr h="324837">
                 <a:tc>
                   <a:txBody>
                     <a:bodyPr/>
@@ -447,7 +447,7 @@
                   </a:tcPr>
                 </a:tc>
               </a:tr>
-              <a:tr h="277214">
+              <a:tr h="281847">
                 <a:tc>
                   <a:txBody>
                     <a:bodyPr/>
@@ -589,7 +589,7 @@
                   </a:tcPr>
                 </a:tc>
               </a:tr>
-              <a:tr h="279685">
+              <a:tr h="272629">
                 <a:tc>
                   <a:txBody>
                     <a:bodyPr/>
@@ -731,7 +731,7 @@
                   </a:tcPr>
                 </a:tc>
               </a:tr>
-              <a:tr h="293988">
+              <a:tr h="287770">
                 <a:tc>
                   <a:txBody>
                     <a:bodyPr/>
@@ -873,7 +873,7 @@
                   </a:tcPr>
                 </a:tc>
               </a:tr>
-              <a:tr h="310940">
+              <a:tr h="319225">
                 <a:tc>
                   <a:txBody>
                     <a:bodyPr/>
@@ -1015,7 +1015,7 @@
                   </a:tcPr>
                 </a:tc>
               </a:tr>
-              <a:tr h="311524">
+              <a:tr h="313333">
                 <a:tc>
                   <a:txBody>
                     <a:bodyPr/>
@@ -1157,7 +1157,7 @@
                   </a:tcPr>
                 </a:tc>
               </a:tr>
-              <a:tr h="267116">
+              <a:tr h="258588">
                 <a:tc>
                   <a:txBody>
                     <a:bodyPr/>
@@ -1332,7 +1332,7 @@
               <a:buNone/>
             </a:pPr>
             <a:r>
-              <a:rPr lang="en-US" sz="2174" spc="196" dirty="0">
+              <a:rPr lang="en-US" sz="2140" spc="196" dirty="0">
                 <a:solidFill>
                   <a:srgbClr val="000000"/>
                 </a:solidFill>
@@ -1353,7 +1353,7 @@
         </p:nvSpPr>
         <p:spPr>
           <a:xfrm>
-            <a:off x="1143877" y="1171620"/>
+            <a:off x="1143877" y="1168844"/>
             <a:ext cx="1974771" cy="114300"/>
           </a:xfrm>
           <a:prstGeom prst="rect">
@@ -1395,7 +1395,7 @@
         </p:nvSpPr>
         <p:spPr>
           <a:xfrm>
-            <a:off x="2522025" y="2148658"/>
+            <a:off x="2522025" y="2134036"/>
             <a:ext cx="2836404" cy="220980"/>
           </a:xfrm>
           <a:prstGeom prst="rect">
@@ -1437,7 +1437,7 @@
         </p:nvSpPr>
         <p:spPr>
           <a:xfrm>
-            <a:off x="3441411" y="2475204"/>
+            <a:off x="3441411" y="2468083"/>
             <a:ext cx="982728" cy="152400"/>
           </a:xfrm>
           <a:prstGeom prst="rect">
@@ -1532,7 +1532,7 @@
         </p:nvSpPr>
         <p:spPr>
           <a:xfrm>
-            <a:off x="1292916" y="6178244"/>
+            <a:off x="1292916" y="6181997"/>
             <a:ext cx="6613619" cy="160020"/>
           </a:xfrm>
           <a:prstGeom prst="rect">
@@ -1575,6 +1575,48 @@
         </p:nvSpPr>
         <p:spPr>
           <a:xfrm>
+            <a:off x="1292916" y="6372952"/>
+            <a:ext cx="498350" cy="152400"/>
+          </a:xfrm>
+          <a:prstGeom prst="rect">
+            <a:avLst/>
+          </a:prstGeom>
+          <a:noFill/>
+        </p:spPr>
+        <p:txBody>
+          <a:bodyPr wrap="none" lIns="0" tIns="0" rIns="0" bIns="0" anchor="t">
+            <a:noAutofit/>
+          </a:bodyPr>
+          <a:lstStyle/>
+          <a:p>
+            <a:pPr algn="l">
+              <a:lnSpc>
+                <a:spcPts val="1200"/>
+              </a:lnSpc>
+              <a:buNone/>
+            </a:pPr>
+            <a:r>
+              <a:rPr lang="en-US" sz="1000" dirty="0">
+                <a:solidFill>
+                  <a:srgbClr val="000000"/>
+                </a:solidFill>
+                <a:latin typeface="Arial"/>
+                <a:ea typeface="Malgun Gothic"/>
+                <a:cs typeface="Arial"/>
+              </a:rPr>
+              <a:t>pe</a:t>
+            </a:r>
+          </a:p>
+        </p:txBody>
+      </p:sp>
+      <p:sp>
+        <p:nvSpPr>
+          <p:cNvPr id="12" name="Text 12"/>
+          <p:cNvSpPr txBox="1"/>
+          <p:nvPr/>
+        </p:nvSpPr>
+        <p:spPr>
+          <a:xfrm>
             <a:off x="1292916" y="6357585"/>
             <a:ext cx="4755285" cy="152400"/>
           </a:xfrm>
@@ -1612,14 +1654,14 @@
       </p:sp>
       <p:sp>
         <p:nvSpPr>
-          <p:cNvPr id="12" name="Text 12"/>
+          <p:cNvPr id="13" name="Text 13"/>
           <p:cNvSpPr txBox="1"/>
           <p:nvPr/>
         </p:nvSpPr>
         <p:spPr>
           <a:xfrm>
-            <a:off x="1241831" y="6529687"/>
-            <a:ext cx="1447128" cy="144780"/>
+            <a:off x="1292916" y="6529687"/>
+            <a:ext cx="1383271" cy="144780"/>
           </a:xfrm>
           <a:prstGeom prst="rect">
             <a:avLst/>
@@ -1632,7 +1674,7 @@
           </a:bodyPr>
           <a:lstStyle/>
           <a:p>
-            <a:pPr algn="l" marL="267192" indent="-267192">
+            <a:pPr algn="l" marL="216107" indent="-216107">
               <a:lnSpc>
                 <a:spcPts val="1140"/>
               </a:lnSpc>
@@ -1655,7 +1697,7 @@
       </p:sp>
       <p:sp>
         <p:nvSpPr>
-          <p:cNvPr id="13" name="Text 13"/>
+          <p:cNvPr id="14" name="Text 14"/>
           <p:cNvSpPr txBox="1"/>
           <p:nvPr/>
         </p:nvSpPr>
@@ -1698,7 +1740,7 @@
       </p:sp>
       <p:sp>
         <p:nvSpPr>
-          <p:cNvPr id="14" name="Text 14"/>
+          <p:cNvPr id="15" name="Text 15"/>
           <p:cNvSpPr txBox="1"/>
           <p:nvPr/>
         </p:nvSpPr>
@@ -1741,7 +1783,7 @@
       </p:sp>
       <p:sp>
         <p:nvSpPr>
-          <p:cNvPr id="15" name="Text 15"/>
+          <p:cNvPr id="16" name="Text 16"/>
           <p:cNvSpPr txBox="1"/>
           <p:nvPr/>
         </p:nvSpPr>
@@ -1769,7 +1811,7 @@
               <a:buChar char="•"/>
             </a:pPr>
             <a:r>
-              <a:rPr lang="en-US" sz="1050" spc="22" dirty="0">
+              <a:rPr lang="en-US" sz="1050" spc="19" dirty="0">
                 <a:solidFill>
                   <a:srgbClr val="000000"/>
                 </a:solidFill>
@@ -1780,7 +1822,7 @@
               <a:t>Certified cheques or bank drafts made out to</a:t>
             </a:r>
             <a:r>
-              <a:rPr lang="en-US" sz="1050" b="1" spc="22" dirty="0">
+              <a:rPr lang="en-US" sz="1050" b="1" spc="19" dirty="0">
                 <a:solidFill>
                   <a:srgbClr val="000000"/>
                 </a:solidFill>
@@ -1795,14 +1837,14 @@
       </p:sp>
       <p:sp>
         <p:nvSpPr>
-          <p:cNvPr id="16" name="Text 16"/>
+          <p:cNvPr id="17" name="Text 17"/>
           <p:cNvSpPr txBox="1"/>
           <p:nvPr/>
         </p:nvSpPr>
         <p:spPr>
           <a:xfrm>
-            <a:off x="1080535" y="7909155"/>
-            <a:ext cx="5718266" cy="194818"/>
+            <a:off x="1065631" y="7920064"/>
+            <a:ext cx="5768157" cy="194818"/>
           </a:xfrm>
           <a:prstGeom prst="rect">
             <a:avLst/>
@@ -1822,7 +1864,7 @@
               <a:buNone/>
             </a:pPr>
             <a:r>
-              <a:rPr lang="en-US" sz="650" spc="11" dirty="0">
+              <a:rPr lang="en-US" sz="650" spc="9" dirty="0">
                 <a:solidFill>
                   <a:srgbClr val="000000"/>
                 </a:solidFill>
@@ -1830,7 +1872,7 @@
                 <a:ea typeface="Malgun Gothic"/>
                 <a:cs typeface="Arial"/>
               </a:rPr>
-              <a:t>Prices do not include GST, may change without notice and are subject to availability. Sulte sizes may vary on final Strata Plan. Concert reserves the right to</a:t>
+              <a:t>Prices do not include GST, may change without notice and are subject to availability. Suite sizes may vary on final Strata Plan. Concert reserves the right to</a:t>
             </a:r>
             <a:r>
               <a:rPr lang="en-US" sz="650" dirty="0">
@@ -1844,7 +1886,7 @@
               <a:t> </a:t>
             </a:r>
             <a:r>
-              <a:rPr lang="en-US" sz="600" spc="11" dirty="0">
+              <a:rPr lang="en-US" sz="600" spc="9" dirty="0">
                 <a:solidFill>
                   <a:srgbClr val="000000"/>
                 </a:solidFill>
@@ -1852,21 +1894,21 @@
                 <a:ea typeface="Malgun Gothic"/>
                 <a:cs typeface="Arial"/>
               </a:rPr>
-              <a:t>nake modifications and changes to floorplans, project design, specifications and features. October 2021. CONCERT REALTY SERVICES LTD. E.8O.!</a:t>
+              <a:t>make modifications and changes to floorplans, project design, specifications and features. October 2021. CONCERT REALTY SERVICES LTD. E.&amp;O.E.</a:t>
             </a:r>
           </a:p>
         </p:txBody>
       </p:sp>
       <p:sp>
         <p:nvSpPr>
-          <p:cNvPr id="17" name="Text 17"/>
+          <p:cNvPr id="18" name="Text 18"/>
           <p:cNvSpPr txBox="1"/>
           <p:nvPr/>
         </p:nvSpPr>
         <p:spPr>
           <a:xfrm>
             <a:off x="1069357" y="8798979"/>
-            <a:ext cx="2370657" cy="248579"/>
+            <a:ext cx="2370657" cy="233957"/>
           </a:xfrm>
           <a:prstGeom prst="rect">
             <a:avLst/>
@@ -1881,7 +1923,7 @@
           <a:p>
             <a:pPr algn="l">
               <a:lnSpc>
-                <a:spcPts val="979"/>
+                <a:spcPts val="921"/>
               </a:lnSpc>
               <a:buNone/>
             </a:pPr>
@@ -1908,14 +1950,14 @@
                 <a:ea typeface="Malgun Gothic"/>
                 <a:cs typeface="Arial"/>
               </a:rPr>
-              <a:t>101 - 511 Clarke Road, Coquitlam, BC V3J 0J1</a:t>
+              <a:t>101 - 511 Clarke Road, Coquitlam, BC V3J 0/1</a:t>
             </a:r>
           </a:p>
         </p:txBody>
       </p:sp>
       <p:sp>
         <p:nvSpPr>
-          <p:cNvPr id="18" name="Text 18"/>
+          <p:cNvPr id="19" name="Text 19"/>
           <p:cNvSpPr txBox="1"/>
           <p:nvPr/>
         </p:nvSpPr>
@@ -1956,13 +1998,13 @@
       </p:sp>
       <p:sp>
         <p:nvSpPr>
-          <p:cNvPr id="19" name="Text 19"/>
+          <p:cNvPr id="20" name="Text 20"/>
           <p:cNvSpPr txBox="1"/>
           <p:nvPr/>
         </p:nvSpPr>
         <p:spPr>
           <a:xfrm>
-            <a:off x="5827437" y="9059864"/>
+            <a:off x="5827437" y="9052553"/>
             <a:ext cx="1248204" cy="114300"/>
           </a:xfrm>
           <a:prstGeom prst="rect">
@@ -1990,7 +2032,7 @@
                 <a:ea typeface="Malgun Gothic"/>
                 <a:cs typeface="Arial"/>
               </a:rPr>
-              <a:t>CONCERT®</a:t>
+              <a:t>CONCERT'</a:t>
             </a:r>
           </a:p>
         </p:txBody>

</xml_diff>